<commit_message>
Informe y presentación actualizados con la arquitectura de servidores MCP
</commit_message>
<xml_diff>
--- a/_entregas/MALI_Asistente_Presentacion.pptx
+++ b/_entregas/MALI_Asistente_Presentacion.pptx
@@ -126,32 +126,32 @@
   <p:extLst>
     <p:ext uri="{521415D9-36F7-43E2-AB2F-B90AF26B5E84}">
       <p14:sectionLst xmlns:p14="http://schemas.microsoft.com/office/powerpoint/2010/main">
-        <p14:section name="Inicio" id="{60bf9495-e97e-dbec-f17b-c2d8221317f4}">
+        <p14:section name="Inicio" id="{1b410a2f-753a-d528-ce5c-09a27457f5c2}">
           <p14:sldIdLst>
             <p14:sldId id="256"/>
             <p14:sldId id="257"/>
           </p14:sldIdLst>
         </p14:section>
-        <p14:section name="1. Problema" id="{be6de85d-61d3-299c-4900-2fe784647eb7}">
+        <p14:section name="1. Problema" id="{82c71b6c-6d87-5824-9280-e9eb946b3f6c}">
           <p14:sldIdLst>
             <p14:sldId id="258"/>
             <p14:sldId id="259"/>
           </p14:sldIdLst>
         </p14:section>
-        <p14:section name="2. Fundamentos y técnica" id="{a1d78e06-885e-6c58-d9e0-edc1c32f06d8}">
+        <p14:section name="2. Fundamentos y técnica" id="{3b212814-ef1d-e4bc-3a23-979c18bd3bbd}">
           <p14:sldIdLst>
             <p14:sldId id="260"/>
             <p14:sldId id="261"/>
             <p14:sldId id="262"/>
           </p14:sldIdLst>
         </p14:section>
-        <p14:section name="3. Datos" id="{c492c870-6971-15fb-fa10-afabfd79c09b}">
+        <p14:section name="3. Datos" id="{f68bc7cf-63c9-39a2-f505-8bc7976a9ecc}">
           <p14:sldIdLst>
             <p14:sldId id="263"/>
             <p14:sldId id="264"/>
           </p14:sldIdLst>
         </p14:section>
-        <p14:section name="4. Modelo y evaluación" id="{eddfa889-f0b8-d700-b452-d53a09c12225}">
+        <p14:section name="4. Modelo y evaluación" id="{aa52979d-66d8-4dd1-e1b7-a6d361b8eaf5}">
           <p14:sldIdLst>
             <p14:sldId id="265"/>
             <p14:sldId id="266"/>
@@ -160,18 +160,18 @@
             <p14:sldId id="269"/>
           </p14:sldIdLst>
         </p14:section>
-        <p14:section name="5. Análisis crítico" id="{14c1ec45-d22a-d455-435c-90bfbef5b011}">
+        <p14:section name="5. Análisis crítico" id="{f0b02042-5d69-507f-2b39-56fcf34656ac}">
           <p14:sldIdLst>
             <p14:sldId id="270"/>
             <p14:sldId id="271"/>
           </p14:sldIdLst>
         </p14:section>
-        <p14:section name="7. Aporte" id="{cf48f34e-70a0-ac37-5cd7-db9644399297}">
+        <p14:section name="7. Aporte" id="{5d16c9b2-d947-6836-5dad-39b2492c602a}">
           <p14:sldIdLst>
             <p14:sldId id="272"/>
           </p14:sldIdLst>
         </p14:section>
-        <p14:section name="Cierre" id="{81145e3a-58f7-53c0-7c3e-c29ad619a0bb}">
+        <p14:section name="Cierre" id="{d596385d-ebb0-f708-5920-be0118e353d2}">
           <p14:sldIdLst>
             <p14:sldId id="273"/>
             <p14:sldId id="274"/>
@@ -3187,7 +3187,7 @@
           <a:p>
             <a:r>
               <a:rPr lang="en-US" dirty="0"/>
-              <a:t>Un orquestador decide cómo se atiende cada mensaje: primero los controles de seguridad, luego los datos exactos directamente desde los archivos y solo al final el modelo, que redacta a partir de fragmentos recuperados. Así el modelo nunca toca datos personales.</a:t>
+              <a:t>Un orquestador decide cómo se atiende cada mensaje: primero los controles de seguridad, luego los datos exactos, que obtiene como cliente de dos servidores MCP (uno general y otro restringido), y solo al final el modelo, que redacta a partir de fragmentos recuperados. Así el modelo nunca toca datos personales.</a:t>
             </a:r>
             <a:endParaRPr lang="en-US" dirty="0"/>
           </a:p>
@@ -10925,7 +10925,7 @@
                   <a:schemeClr val="tx1"/>
                 </a:solidFill>
               </a:rPr>
-              <a:t>Phi-4-mini en Foundry Local; MCP solo con información general</a:t>
+              <a:t>Phi-4-mini local; MCP general y MCP restringido separan los datos</a:t>
             </a:r>
             <a:endParaRPr lang="en-US" sz="1300" dirty="0"/>
           </a:p>
@@ -15932,7 +15932,7 @@
                   <a:schemeClr val="tx1"/>
                 </a:solidFill>
               </a:rPr>
-              <a:t>Protocolo para exponer herramientas al modelo; solo nivel general</a:t>
+              <a:t>Protocolo para conectar datos y herramientas: servidor general y restringido</a:t>
             </a:r>
             <a:endParaRPr lang="en-US" sz="1300" dirty="0"/>
           </a:p>
@@ -17358,7 +17358,7 @@
                   <a:schemeClr val="tx1"/>
                 </a:solidFill>
               </a:rPr>
-              <a:t>Vacantes, matrícula, pagos y alumnos sin pasar por el modelo</a:t>
+              <a:t>Vacantes, matrícula, pagos y alumnos por los servidores MCP, sin el modelo</a:t>
             </a:r>
             <a:endParaRPr lang="en-US" sz="1400" dirty="0"/>
           </a:p>
@@ -17474,7 +17474,7 @@
                   <a:schemeClr val="tx1"/>
                 </a:solidFill>
               </a:rPr>
-              <a:t>BM25 recupera y Phi-4-mini redacta con fuente</a:t>
+              <a:t>BM25 (MCP general) recupera y Phi-4-mini redacta con fuente</a:t>
             </a:r>
             <a:endParaRPr lang="en-US" sz="1400" dirty="0"/>
           </a:p>

</xml_diff>